<commit_message>
docs: refine deck visuals after render review
Co-authored-by: Mohamed  <garlobrian52@users.noreply.github.com>
</commit_message>
<xml_diff>
--- a/deliverables/apple-fy2025-environmental-progress.pptx
+++ b/deliverables/apple-fy2025-environmental-progress.pptx
@@ -443,7 +443,7 @@
                   <c:v>Reduction</c:v>
                 </c:pt>
                 <c:pt idx="1">
-                  <c:v>To target</c:v>
+                  <c:v>Remaining</c:v>
                 </c:pt>
               </c:strCache>
             </c:strRef>
@@ -457,7 +457,7 @@
                   <c:v>60</c:v>
                 </c:pt>
                 <c:pt idx="1">
-                  <c:v>15</c:v>
+                  <c:v>40</c:v>
                 </c:pt>
               </c:numCache>
             </c:numRef>
@@ -6872,21 +6872,21 @@
           <p:nvPr/>
         </p:nvSpPr>
         <p:spPr>
-          <a:xfrm rot="-1080000">
+          <a:xfrm rot="2880000">
             <a:off x="9427464" y="2221992"/>
-            <a:ext cx="637337" cy="412394"/>
-          </a:xfrm>
-          <a:prstGeom prst="arc">
+            <a:ext cx="464881" cy="614843"/>
+          </a:xfrm>
+          <a:prstGeom prst="teardrop">
             <a:avLst/>
           </a:prstGeom>
           <a:solidFill>
-            <a:srgbClr val="2CB7A7">
-              <a:alpha val="0"/>
-            </a:srgbClr>
+            <a:srgbClr val="2CB7A7"/>
           </a:solidFill>
           <a:ln w="12700">
             <a:solidFill>
-              <a:srgbClr val="2CB7A7"/>
+              <a:srgbClr val="2CB7A7">
+                <a:alpha val="0"/>
+              </a:srgbClr>
             </a:solidFill>
             <a:prstDash val="solid"/>
           </a:ln>
@@ -6900,8 +6900,8 @@
         </p:nvSpPr>
         <p:spPr>
           <a:xfrm>
-            <a:off x="9532437" y="2566904"/>
-            <a:ext cx="457383" cy="-254935"/>
+            <a:off x="9494947" y="2724363"/>
+            <a:ext cx="359908" cy="-314919"/>
           </a:xfrm>
           <a:prstGeom prst="line">
             <a:avLst/>
@@ -6909,7 +6909,9 @@
           <a:noFill/>
           <a:ln w="12700">
             <a:solidFill>
-              <a:srgbClr val="2CB7A7"/>
+              <a:srgbClr val="FFFFFF">
+                <a:alpha val="76000"/>
+              </a:srgbClr>
             </a:solidFill>
             <a:prstDash val="solid"/>
           </a:ln>
@@ -9151,21 +9153,21 @@
           <p:nvPr/>
         </p:nvSpPr>
         <p:spPr>
-          <a:xfrm rot="-1080000">
+          <a:xfrm rot="2880000">
             <a:off x="9473184" y="2688336"/>
-            <a:ext cx="427482" cy="276606"/>
-          </a:xfrm>
-          <a:prstGeom prst="arc">
+            <a:ext cx="311810" cy="412394"/>
+          </a:xfrm>
+          <a:prstGeom prst="teardrop">
             <a:avLst/>
           </a:prstGeom>
           <a:solidFill>
-            <a:srgbClr val="0A8F62">
-              <a:alpha val="0"/>
-            </a:srgbClr>
+            <a:srgbClr val="0A8F62"/>
           </a:solidFill>
           <a:ln w="12700">
             <a:solidFill>
-              <a:srgbClr val="0A8F62"/>
+              <a:srgbClr val="0A8F62">
+                <a:alpha val="0"/>
+              </a:srgbClr>
             </a:solidFill>
             <a:prstDash val="solid"/>
           </a:ln>
@@ -9179,8 +9181,8 @@
         </p:nvSpPr>
         <p:spPr>
           <a:xfrm>
-            <a:off x="9543593" y="2919679"/>
-            <a:ext cx="306781" cy="-170993"/>
+            <a:off x="9518447" y="3025292"/>
+            <a:ext cx="241402" cy="-211226"/>
           </a:xfrm>
           <a:prstGeom prst="line">
             <a:avLst/>
@@ -9188,7 +9190,9 @@
           <a:noFill/>
           <a:ln w="12700">
             <a:solidFill>
-              <a:srgbClr val="0A8F62"/>
+              <a:srgbClr val="FFFFFF">
+                <a:alpha val="76000"/>
+              </a:srgbClr>
             </a:solidFill>
             <a:prstDash val="solid"/>
           </a:ln>

</xml_diff>